<commit_message>
﻿docs(deck): record that the advisory model was sized to the job, and rebuild
Adds one bullet to Slide 12 and regenerates the PPT.

A mentor observed that a frontier model is oversized for rewriting a
180-character sentence. Rather than assert a choice, both were measured on the
same three advisories: claude-opus-5 and claude-haiku-4-5 each passed the
advisory guard 3/3 with every number preserved, and Haiku ran 2.2x faster at a
fifth of the cost.

That is direct evidence for the criterion the orientation slides weight most
heavily -- AI Architecture and Model Fit is 30% of Technical Soundness, 15% of
the total, and scores 'did you pick the right tool for the job'. 'We measured
that the smallest model does this job identically' answers it; 'we used the
biggest one' does not.

The bullet also notes the layer is a slot rather than a dependency: the guard is
provider-agnostic and Gemini passes it too.

Deck regenerated from DECK.md, 18 slides. Never hand-edited.
</commit_message>
<xml_diff>
--- a/docs/Marine-AI-Pitch-Deck.pptx
+++ b/docs/Marine-AI-Pitch-Deck.pptx
@@ -7041,6 +7041,94 @@
                 <a:latin typeface="Segoe UI"/>
               </a:rPr>
               <a:t> on every frame names who wrote what the captain is reading.</a:t>
+            </a:r>
+          </a:p>
+          <a:p>
+            <a:pPr>
+              <a:spcAft>
+                <a:spcPts val="900"/>
+              </a:spcAft>
+            </a:pPr>
+            <a:r>
+              <a:rPr sz="1600">
+                <a:solidFill>
+                  <a:srgbClr val="F97316"/>
+                </a:solidFill>
+                <a:latin typeface="Segoe UI"/>
+              </a:rPr>
+              <a:t>— </a:t>
+            </a:r>
+            <a:r>
+              <a:rPr sz="1600" b="1">
+                <a:solidFill>
+                  <a:srgbClr val="F8FAFC"/>
+                </a:solidFill>
+                <a:latin typeface="Segoe UI"/>
+              </a:rPr>
+              <a:t>The model is sized to the job, and we measured it.</a:t>
+            </a:r>
+            <a:r>
+              <a:rPr sz="1600" b="0">
+                <a:solidFill>
+                  <a:srgbClr val="F8FAFC"/>
+                </a:solidFill>
+                <a:latin typeface="Segoe UI"/>
+              </a:rPr>
+              <a:t> Rewriting one 180-character sentence does not need a frontier model. Both were run on the same three advisories: </a:t>
+            </a:r>
+            <a:r>
+              <a:rPr sz="1400" b="0">
+                <a:solidFill>
+                  <a:srgbClr val="B6C2D4"/>
+                </a:solidFill>
+                <a:latin typeface="Consolas"/>
+              </a:rPr>
+              <a:t>claude-opus-5</a:t>
+            </a:r>
+            <a:r>
+              <a:rPr sz="1600" b="0">
+                <a:solidFill>
+                  <a:srgbClr val="F8FAFC"/>
+                </a:solidFill>
+                <a:latin typeface="Segoe UI"/>
+              </a:rPr>
+              <a:t> and </a:t>
+            </a:r>
+            <a:r>
+              <a:rPr sz="1400" b="0">
+                <a:solidFill>
+                  <a:srgbClr val="B6C2D4"/>
+                </a:solidFill>
+                <a:latin typeface="Consolas"/>
+              </a:rPr>
+              <a:t>claude-haiku-4-5</a:t>
+            </a:r>
+            <a:r>
+              <a:rPr sz="1600" b="0">
+                <a:solidFill>
+                  <a:srgbClr val="F8FAFC"/>
+                </a:solidFill>
+                <a:latin typeface="Segoe UI"/>
+              </a:rPr>
+              <a:t> each passed the guard 3/3 with every number preserved, and Haiku was </a:t>
+            </a:r>
+            <a:r>
+              <a:rPr sz="1600" b="1">
+                <a:solidFill>
+                  <a:srgbClr val="F8FAFC"/>
+                </a:solidFill>
+                <a:latin typeface="Segoe UI"/>
+              </a:rPr>
+              <a:t>2.2× faster at ⅕ the cost</a:t>
+            </a:r>
+            <a:r>
+              <a:rPr sz="1600" b="0">
+                <a:solidFill>
+                  <a:srgbClr val="F8FAFC"/>
+                </a:solidFill>
+                <a:latin typeface="Segoe UI"/>
+              </a:rPr>
+              <a:t>. The guard is provider-agnostic by design — Gemini passes it too — so the layer is a slot, not a dependency.</a:t>
             </a:r>
           </a:p>
         </p:txBody>

</xml_diff>

<commit_message>
docs(deck): rebuild the PPT with the shipped model named
Regenerated from DECK.md after the Haiku decision. The slide keeps both model
names because the point is that the choice was measured, not asserted.
</commit_message>
<xml_diff>
--- a/docs/Marine-AI-Pitch-Deck.pptx
+++ b/docs/Marine-AI-Pitch-Deck.pptx
@@ -7120,6 +7120,24 @@
                 <a:latin typeface="Segoe UI"/>
               </a:rPr>
               <a:t>2.2× faster at ⅕ the cost</a:t>
+            </a:r>
+            <a:r>
+              <a:rPr sz="1600" b="0">
+                <a:solidFill>
+                  <a:srgbClr val="F8FAFC"/>
+                </a:solidFill>
+                <a:latin typeface="Segoe UI"/>
+              </a:rPr>
+              <a:t> — so </a:t>
+            </a:r>
+            <a:r>
+              <a:rPr sz="1600" b="1">
+                <a:solidFill>
+                  <a:srgbClr val="F8FAFC"/>
+                </a:solidFill>
+                <a:latin typeface="Segoe UI"/>
+              </a:rPr>
+              <a:t>Haiku is what ships</a:t>
             </a:r>
             <a:r>
               <a:rPr sz="1600" b="0">

</xml_diff>